<commit_message>
Rename coop docs to generic wording, add Oba village data, outreach and meeting docs; ignore docs/private
people_register.md held back pending redaction of private contact details.

Co-Authored-By: Claude Sonnet 5.5 <noreply@anthropic.com>
</commit_message>
<xml_diff>
--- a/decks/Mitsue Project Presentation (Komatsu draft).pptx
+++ b/decks/Mitsue Project Presentation (Komatsu draft).pptx
@@ -1526,7 +1526,7 @@
           <a:lstStyle/>
           <a:p>
             <a:r>
-              <a:t>PRIVACY: the young person is deliberately NOT named. She is Kinjo-san's daughter and works at the cooperative; Kinjo said on 19 Oct that she is eager to learn heavy machinery such as the 931XC. Rob wants to promote women in the forestry workforce (positive angle for Komatsu). Keep it to workforce diversity; the deck lists non-partisan as an operating principle, so no political references on the slide. No national share of women in forestry is quoted because it is unverified. Confirm with Kinjo-san and her daughter before naming her or describing her in more detail, and keep to her qualities, never her looks. Nothing is decided: no training slot, licence route or machine access has been checked (see earlier note of 9 Oct). Cooperative crew: small, few young people (Rob, 19 Oct 2026); the workforce plan lists the crew as small and young (average age ~33), so do not quote an age.</a:t>
+              <a:t>PRIVACY: the young person is deliberately NOT named. She is Kinjo-san's daughter and works at the cooperative; Kinjo said on 19 Oct that she is eager to learn heavy machinery such as the 931XC. Rob wants to promote women in the forestry workforce (positive angle for Komatsu). Keep it to workforce diversity; the deck lists non-partisan as an operating principle, so no political references on the slide. No national share of women in forestry is quoted because it is unverified. Confirm with Kinjo-san and her daughter before naming her or describing her in more detail, and keep to her qualities, never her looks. Nothing is decided: no training slot, licence route or machine access has been checked (see earlier note of 9 Oct). Cooperative crew: small, few young people (Rob, 19 Oct 2026); the workforce plan lists the crew as small and young (average age ~33), so do not quote an age. UPDATE 25 Oct: dream job is operator, but she may need to take another job first (cooking/food company); timing uncertain. Slide wording kept soft; do not mention the other job.</a:t>
             </a:r>
           </a:p>
         </p:txBody>
@@ -4739,7 +4739,7 @@
                 </a:solidFill>
                 <a:latin typeface="Courier New"/>
               </a:rPr>
-              <a:t>PREPARED FOR KOMATSU LTD. · TEAMS MEETING 27 OCT 2026 · DRAFT</a:t>
+              <a:t>PREPARED FOR KOMATSU LTD. · TEAMS MEETING 27 OCT 2026</a:t>
             </a:r>
           </a:p>
         </p:txBody>
@@ -5223,7 +5223,7 @@
                 </a:solidFill>
                 <a:latin typeface="Courier New"/>
               </a:rPr>
-              <a:t>PREPARED FOR KOMATSU LTD. · TEAMS MEETING 27 OCT 2026 · DRAFT</a:t>
+              <a:t>PREPARED FOR KOMATSU LTD. · TEAMS MEETING 27 OCT 2026</a:t>
             </a:r>
           </a:p>
         </p:txBody>
@@ -5777,7 +5777,7 @@
                 </a:solidFill>
                 <a:latin typeface="Georgia"/>
               </a:rPr>
-              <a:t>Phase 1</a:t>
+              <a:t>Next step</a:t>
             </a:r>
           </a:p>
         </p:txBody>
@@ -6517,7 +6517,7 @@
                 </a:solidFill>
                 <a:latin typeface="Courier New"/>
               </a:rPr>
-              <a:t>PREPARED FOR KOMATSU LTD. · TEAMS MEETING 27 OCT 2026 · DRAFT</a:t>
+              <a:t>PREPARED FOR KOMATSU LTD. · TEAMS MEETING 27 OCT 2026</a:t>
             </a:r>
           </a:p>
         </p:txBody>
@@ -7423,7 +7423,7 @@
                 </a:solidFill>
                 <a:latin typeface="Courier New"/>
               </a:rPr>
-              <a:t>PREPARED FOR KOMATSU LTD. · TEAMS MEETING 27 OCT 2026 · DRAFT</a:t>
+              <a:t>PREPARED FOR KOMATSU LTD. · TEAMS MEETING 27 OCT 2026</a:t>
             </a:r>
           </a:p>
         </p:txBody>
@@ -7564,7 +7564,7 @@
                 </a:solidFill>
                 <a:latin typeface="Arial"/>
               </a:rPr>
-              <a:t>4  Training options for a young woman who wants to learn to operate the machines, and how to bring more women into forestry work.</a:t>
+              <a:t>4  Training options for a young woman who dreams of becoming an operator, at a time that suits her, and how to bring more women into forestry work.</a:t>
             </a:r>
           </a:p>
         </p:txBody>
@@ -8036,7 +8036,7 @@
                 </a:solidFill>
                 <a:latin typeface="Courier New"/>
               </a:rPr>
-              <a:t>PREPARED FOR KOMATSU LTD. · TEAMS MEETING 27 OCT 2026 · DRAFT</a:t>
+              <a:t>PREPARED FOR KOMATSU LTD. · TEAMS MEETING 27 OCT 2026</a:t>
             </a:r>
           </a:p>
         </p:txBody>
@@ -8814,7 +8814,7 @@
                 </a:solidFill>
                 <a:latin typeface="Courier New"/>
               </a:rPr>
-              <a:t>PREPARED FOR KOMATSU LTD. · TEAMS MEETING 27 OCT 2026 · DRAFT</a:t>
+              <a:t>PREPARED FOR KOMATSU LTD. · TEAMS MEETING 27 OCT 2026</a:t>
             </a:r>
           </a:p>
         </p:txBody>
@@ -9346,7 +9346,7 @@
                 </a:solidFill>
                 <a:latin typeface="Courier New"/>
               </a:rPr>
-              <a:t>PREPARED FOR KOMATSU LTD. · TEAMS MEETING 27 OCT 2026 · DRAFT</a:t>
+              <a:t>PREPARED FOR KOMATSU LTD. · TEAMS MEETING 27 OCT 2026</a:t>
             </a:r>
           </a:p>
         </p:txBody>
@@ -10464,7 +10464,7 @@
                 </a:solidFill>
                 <a:latin typeface="Courier New"/>
               </a:rPr>
-              <a:t>PREPARED FOR KOMATSU LTD. · TEAMS MEETING 27 OCT 2026 · DRAFT</a:t>
+              <a:t>PREPARED FOR KOMATSU LTD. · TEAMS MEETING 27 OCT 2026</a:t>
             </a:r>
           </a:p>
         </p:txBody>
@@ -10610,52 +10610,30 @@
           </a:p>
         </p:txBody>
       </p:sp>
-      <p:sp>
-        <p:nvSpPr>
-          <p:cNvPr id="10" name="Rectangle 9"/>
-          <p:cNvSpPr/>
-          <p:nvPr/>
-        </p:nvSpPr>
+      <p:pic>
+        <p:nvPicPr>
+          <p:cNvPr id="10" name="Picture 9" descr="site.jpg"/>
+          <p:cNvPicPr>
+            <a:picLocks noChangeAspect="1"/>
+          </p:cNvPicPr>
+          <p:nvPr/>
+        </p:nvPicPr>
+        <p:blipFill>
+          <a:blip r:embed="rId3"/>
+          <a:stretch>
+            <a:fillRect/>
+          </a:stretch>
+        </p:blipFill>
         <p:spPr>
           <a:xfrm>
             <a:off x="9875520" y="3566160"/>
-            <a:ext cx="7589520" cy="5486400"/>
-          </a:xfrm>
-          <a:prstGeom prst="rect">
-            <a:avLst/>
-          </a:prstGeom>
-          <a:solidFill>
-            <a:srgbClr val="ECE3D3"/>
-          </a:solidFill>
-          <a:ln w="19050">
-            <a:solidFill>
-              <a:srgbClr val="4C554F"/>
-            </a:solidFill>
-          </a:ln>
-          <a:effectLst/>
-        </p:spPr>
-        <p:style>
-          <a:lnRef idx="1">
-            <a:schemeClr val="accent1"/>
-          </a:lnRef>
-          <a:fillRef idx="3">
-            <a:schemeClr val="accent1"/>
-          </a:fillRef>
-          <a:effectRef idx="2">
-            <a:schemeClr val="accent1"/>
-          </a:effectRef>
-          <a:fontRef idx="minor">
-            <a:schemeClr val="lt1"/>
-          </a:fontRef>
-        </p:style>
-        <p:txBody>
-          <a:bodyPr rtlCol="0" anchor="ctr"/>
-          <a:lstStyle/>
-          <a:p>
-            <a:pPr algn="ctr"/>
-          </a:p>
-        </p:txBody>
-      </p:sp>
+            <a:ext cx="7589520" cy="5203350"/>
+          </a:xfrm>
+          <a:prstGeom prst="rect">
+            <a:avLst/>
+          </a:prstGeom>
+        </p:spPr>
+      </p:pic>
       <p:sp>
         <p:nvSpPr>
           <p:cNvPr id="11" name="TextBox 10"/>
@@ -10664,8 +10642,8 @@
         </p:nvSpPr>
         <p:spPr>
           <a:xfrm>
-            <a:off x="10149840" y="5212080"/>
-            <a:ext cx="7040880" cy="2194560"/>
+            <a:off x="9875520" y="8845710"/>
+            <a:ext cx="7589520" cy="330200"/>
           </a:xfrm>
           <a:prstGeom prst="rect">
             <a:avLst/>
@@ -10673,46 +10651,19 @@
           <a:noFill/>
         </p:spPr>
         <p:txBody>
-          <a:bodyPr wrap="square" lIns="45720" rIns="45720" tIns="27432" bIns="27432" anchor="t">
+          <a:bodyPr wrap="square">
             <a:spAutoFit/>
           </a:bodyPr>
           <a:lstStyle/>
           <a:p>
-            <a:pPr algn="ctr">
-              <a:lnSpc>
-                <a:spcPct val="110000"/>
-              </a:lnSpc>
-              <a:spcAft>
-                <a:spcPts val="600"/>
-              </a:spcAft>
-            </a:pPr>
-            <a:r>
-              <a:rPr sz="2600" b="1">
-                <a:solidFill>
-                  <a:srgbClr val="2F4A37"/>
-                </a:solidFill>
-                <a:latin typeface="Georgia"/>
-              </a:rPr>
-              <a:t>Photos of the planned site</a:t>
-            </a:r>
-          </a:p>
-          <a:p>
-            <a:pPr algn="ctr">
-              <a:lnSpc>
-                <a:spcPct val="110000"/>
-              </a:lnSpc>
-              <a:spcAft>
-                <a:spcPts val="600"/>
-              </a:spcAft>
-            </a:pPr>
-            <a:r>
-              <a:rPr sz="2000" b="0">
+            <a:r>
+              <a:rPr sz="1400">
                 <a:solidFill>
                   <a:srgbClr val="4C554F"/>
                 </a:solidFill>
-                <a:latin typeface="Arial"/>
-              </a:rPr>
-              <a:t>to be added once the cooperative sends them</a:t>
+                <a:latin typeface="Yu Gothic"/>
+              </a:rPr>
+              <a:t>Aerial view of the probable site (not final)</a:t>
             </a:r>
           </a:p>
         </p:txBody>
@@ -10984,7 +10935,7 @@
                 </a:solidFill>
                 <a:latin typeface="Courier New"/>
               </a:rPr>
-              <a:t>PREPARED FOR KOMATSU LTD. · TEAMS MEETING 27 OCT 2026 · DRAFT</a:t>
+              <a:t>PREPARED FOR KOMATSU LTD. · TEAMS MEETING 27 OCT 2026</a:t>
             </a:r>
           </a:p>
         </p:txBody>
@@ -11907,7 +11858,7 @@
                 </a:solidFill>
                 <a:latin typeface="Courier New"/>
               </a:rPr>
-              <a:t>PREPARED FOR KOMATSU LTD. · TEAMS MEETING 27 OCT 2026 · DRAFT</a:t>
+              <a:t>PREPARED FOR KOMATSU LTD. · TEAMS MEETING 27 OCT 2026</a:t>
             </a:r>
           </a:p>
         </p:txBody>
@@ -13029,7 +12980,7 @@
                 </a:solidFill>
                 <a:latin typeface="Courier New"/>
               </a:rPr>
-              <a:t>PREPARED FOR KOMATSU LTD. · TEAMS MEETING 27 OCT 2026 · DRAFT</a:t>
+              <a:t>PREPARED FOR KOMATSU LTD. · TEAMS MEETING 27 OCT 2026</a:t>
             </a:r>
           </a:p>
         </p:txBody>
@@ -14011,7 +13962,7 @@
                 </a:solidFill>
                 <a:latin typeface="Courier New"/>
               </a:rPr>
-              <a:t>PREPARED FOR KOMATSU LTD. · TEAMS MEETING 27 OCT 2026 · DRAFT</a:t>
+              <a:t>PREPARED FOR KOMATSU LTD. · TEAMS MEETING 27 OCT 2026</a:t>
             </a:r>
           </a:p>
         </p:txBody>
@@ -14429,13 +14380,13 @@
               </a:spcAft>
             </a:pPr>
             <a:r>
-              <a:rPr sz="2400" b="0">
+              <a:rPr sz="2300" b="0">
                 <a:solidFill>
                   <a:srgbClr val="1F2A24"/>
                 </a:solidFill>
                 <a:latin typeface="Arial"/>
               </a:rPr>
-              <a:t>A young woman who works at the cooperative, bright and determined, and eager to learn to operate machines like the 931XC.</a:t>
+              <a:t>A young woman who works at the cooperative, bright and determined. Her dream job is to be a machine operator, and she is excited at the idea of training on machines like the 931XC.</a:t>
             </a:r>
           </a:p>
           <a:p>
@@ -14448,13 +14399,13 @@
               </a:spcAft>
             </a:pPr>
             <a:r>
-              <a:rPr sz="2400" b="1">
+              <a:rPr sz="2300" b="1">
                 <a:solidFill>
                   <a:srgbClr val="C4663A"/>
                 </a:solidFill>
                 <a:latin typeface="Arial"/>
               </a:rPr>
-              <a:t>We would like her to train on Komatsu machines if a trial goes ahead.</a:t>
+              <a:t>Her timing is not certain: she may need to take another job first. We would be glad to offer training if a trial goes ahead and the timing suits her.</a:t>
             </a:r>
           </a:p>
         </p:txBody>

</xml_diff>